<commit_message>
Milestone 4: evidence screenshots, row counts, Cloud SQL script fix, slide 2 IPs
</commit_message>
<xml_diff>
--- a/docs/milestone4/gridpulse_milestone4.pptx
+++ b/docs/milestone4/gridpulse_milestone4.pptx
@@ -108,7 +108,7 @@
   <p:extLst>
     <p:ext uri="{521415D9-36F7-43E2-AB2F-B90AF26B5E84}">
       <p14:sectionLst xmlns:p14="http://schemas.microsoft.com/office/powerpoint/2010/main">
-        <p14:section name="Milestone 4" id="{8f11fef8-a6a7-cba3-719d-535d81b1dd61}">
+        <p14:section name="Milestone 4" id="{0eb43ad6-c54e-a7ba-d296-6301705e0f4c}">
           <p14:sldIdLst>
             <p14:sldId id="256"/>
             <p14:sldId id="257"/>
@@ -4555,7 +4555,7 @@
                   <a:schemeClr val="bg1"/>
                 </a:solidFill>
               </a:rPr>
-              <a:t>10.60.x.x   </a:t>
+              <a:t>10.60.0.3   </a:t>
             </a:r>
             <a:pPr algn="l" indent="0" marL="0">
               <a:buNone/>

</xml_diff>